<commit_message>
Add the final report (LaTeX) and the poster
Rebuild the final report from LaTeX source (report/, built with tectonic)
and correct the docs; add the 70x100 cm poster (poster/make_poster.py,
PPTX + PDF); stop calling the paper "published" in the deck.
</commit_message>
<xml_diff>
--- a/NFT_Copymint_Detection_v3.pptx
+++ b/NFT_Copymint_Detection_v3.pptx
@@ -1572,7 +1572,7 @@
               <a:rPr lang="he-IL" sz="1400" dirty="0">
                 <a:cs typeface="Arial"/>
               </a:rPr>
-              <a:t>לוקחים את הגלאי שלהם בדיוק כמו שפורסם — הספים שלהם, קפואים, בלי שום כיול מחדש — ומחליפים סיגנל אחד.</a:t>
+              <a:t>לוקחים את הגלאי שלהם בדיוק כמו שהוא מוגדר במאמר — הספים שלהם, קפואים, בלי שום כיול מחדש — ומחליפים סיגנל אחד.</a:t>
             </a:r>
             <a:br>
               <a:rPr lang="he-IL" sz="1400" dirty="0"/>
@@ -2126,7 +2126,7 @@
               <a:rPr lang="he-IL" sz="1400" dirty="0">
                 <a:cs typeface="Arial"/>
               </a:rPr>
-              <a:t>התוצאה: ארבע־עשרה נקודות יותר טוב בעבודה ש־sHash נבנה בשבילה, כמעט תשע נקודות יותר טוב בגלאי המלא כמו שהמאמר פרסם אותו — אבל גדול מדי בשביל לשמור על הבלוקצ׳יין.</a:t>
+              <a:t>התוצאה: ארבע־עשרה נקודות יותר טוב בעבודה ש־sHash נבנה בשבילה, כמעט תשע נקודות יותר טוב בגלאי המלא כמו שהמאמר מגדיר אותו — אבל גדול מדי בשביל לשמור על הבלוקצ׳יין.</a:t>
             </a:r>
           </a:p>
           <a:p>
@@ -10232,7 +10232,7 @@
                 <a:ea typeface="Arial" pitchFamily="34" charset="-122"/>
                 <a:cs typeface="Arial" pitchFamily="34" charset="-120"/>
               </a:rPr>
-              <a:t>Replacing a broken signal in a published copymint detector</a:t>
+              <a:t>Replacing a broken signal in an NFT copymint detector</a:t>
             </a:r>
             <a:endParaRPr lang="en-US" sz="2400" dirty="0"/>
           </a:p>
@@ -17150,7 +17150,7 @@
                 <a:ea typeface="Arial" pitchFamily="34" charset="-122"/>
                 <a:cs typeface="Arial" pitchFamily="34" charset="-120"/>
               </a:rPr>
-              <a:t>Change one signal. Leave everything else exactly as the paper published it.</a:t>
+              <a:t>Change one signal. Leave everything else exactly as the paper specifies it.</a:t>
             </a:r>
             <a:endParaRPr lang="en-US" sz="2000" dirty="0"/>
           </a:p>
@@ -17245,7 +17245,7 @@
                 <a:ea typeface="Arial" pitchFamily="34" charset="-122"/>
                 <a:cs typeface="Arial" pitchFamily="34" charset="-120"/>
               </a:rPr>
-              <a:t>at its own published settings</a:t>
+              <a:t>at its own settings</a:t>
             </a:r>
             <a:endParaRPr lang="en-US" sz="1800" dirty="0"/>
           </a:p>
@@ -18265,7 +18265,7 @@
                 <a:ea typeface="Arial" pitchFamily="34" charset="-122"/>
                 <a:cs typeface="Arial" pitchFamily="34" charset="-120"/>
               </a:rPr>
-              <a:t>We replaced one piece of a published detector.</a:t>
+              <a:t>We replaced one piece of an existing detector.</a:t>
             </a:r>
             <a:endParaRPr lang="en-US" sz="2100" dirty="0"/>
           </a:p>
@@ -20061,7 +20061,7 @@
                 <a:ea typeface="Arial" pitchFamily="34" charset="-122"/>
                 <a:cs typeface="Arial" pitchFamily="34" charset="-120"/>
               </a:rPr>
-              <a:t>the paper as published, against our swap   ·   slide 17</a:t>
+              <a:t>the paper at its own thresholds, against our swap   ·   slide 17</a:t>
             </a:r>
             <a:endParaRPr lang="en-US" sz="1900" dirty="0"/>
           </a:p>

</xml_diff>

<commit_message>
Add the ORB vs sHash time comparison to every deliverable
Requested at the final presentation. Times the two tasks both signals
perform, fingerprinting a new image and comparing one pair, as used
(imagehash vs OpenCV ORB) and like for like (our bit-exact C sHash vs
OpenCV ORB), with decode excluded on both sides:

- harness: python/geometric/bench_time.py and src/bench/bench_shash.c;
  shash_from_file split into decode + shash_from_rgb, re-verified
  bit-exact on all 12,000 test images
- PROGRESS §6, README, GLOSSARY and the sHash README
- report: "What ORB Costs in Storage and Time", with a time table and chart
- poster: a "space and time" cost panel
- deck: the size-vs-accuracy chart on slide 9, a new slide 10 with Hebrew
  notes, the recap clause, and corrected slide numbers on the demo slide

Fingerprinting costs about the same (C sHash 1.46 ms, ORB 0.94 ms);
comparing a pair is where they differ (about 0.1 us vs 34 ms, still
24 ms at 128 landmarks).
</commit_message>
<xml_diff>
--- a/NFT_Copymint_Detection_v3.pptx
+++ b/NFT_Copymint_Detection_v3.pptx
@@ -17,6 +17,7 @@
     <p:sldId id="262" r:id="rId8"/>
     <p:sldId id="263" r:id="rId9"/>
     <p:sldId id="264" r:id="rId10"/>
+    <p:sldId id="278" r:id="rId29"/>
     <p:sldId id="277" r:id="rId11"/>
     <p:sldId id="265" r:id="rId12"/>
     <p:sldId id="267" r:id="rId13"/>
@@ -2126,7 +2127,7 @@
               <a:rPr lang="he-IL" sz="1400" dirty="0">
                 <a:cs typeface="Arial"/>
               </a:rPr>
-              <a:t>התוצאה: ארבע־עשרה נקודות יותר טוב בעבודה ש־sHash נבנה בשבילה, כמעט תשע נקודות יותר טוב בגלאי המלא כמו שהמאמר מגדיר אותו — אבל גדול מדי בשביל לשמור על הבלוקצ׳יין.</a:t>
+              <a:t>התוצאה: ארבע־עשרה נקודות יותר טוב בעבודה ש־sHash נבנה בשבילה, כמעט תשע נקודות יותר טוב בגלאי המלא כמו שהמאמר מגדיר אותו — אבל גדול מדי בשביל לשמור על הבלוקצ׳יין, ואיטי להשוואה — כ־34 מילישניות לזוג, מול עשירית מיקרו־שנייה ל־sHash.</a:t>
             </a:r>
           </a:p>
           <a:p>
@@ -2278,6 +2279,78 @@
 </p:notes>
 </file>
 
+<file path=ppt/notesSlides/notesSlide23.xml><?xml version="1.0" encoding="utf-8"?>
+<p:notes xmlns:a="http://schemas.openxmlformats.org/drawingml/2006/main" xmlns:p="http://schemas.openxmlformats.org/presentationml/2006/main" xmlns:r="http://schemas.openxmlformats.org/officeDocument/2006/relationships">
+  <p:cSld>
+    <p:spTree>
+      <p:nvGrpSpPr>
+        <p:cNvPr id="1" name=""/>
+        <p:cNvGrpSpPr/>
+        <p:nvPr/>
+      </p:nvGrpSpPr>
+      <p:grpSpPr>
+        <a:xfrm>
+          <a:off x="0" y="0"/>
+          <a:ext cx="0" cy="0"/>
+          <a:chOff x="0" y="0"/>
+          <a:chExt cx="0" cy="0"/>
+        </a:xfrm>
+      </p:grpSpPr>
+      <p:sp>
+        <p:nvSpPr>
+          <p:cNvPr id="3" name="Notes Placeholder 2"/>
+          <p:cNvSpPr>
+            <a:spLocks noGrp="1"/>
+          </p:cNvSpPr>
+          <p:nvPr>
+            <p:ph type="body" idx="1"/>
+          </p:nvPr>
+        </p:nvSpPr>
+        <p:spPr/>
+        <p:txBody>
+          <a:bodyPr/>
+          <a:lstStyle/>
+          <a:p>
+            <a:r>
+              <a:t>אותו דבר, רק בזמן. מדדנו את שתי הפעולות ששני הסיגנלים עושים.</a:t>
+            </a:r>
+          </a:p>
+          <a:p>
+            <a:r>
+              <a:t>הראשונה — ליצור טביעת אצבע לתמונה חדשה: ORB מוצא ומתאר נקודות ציון, ו־sHash מחלק את התמונה לאובייקטים העיקריים שלה ועושה hash לכל אחד. כאן הם בערך שווים — מילישנייה וחצי ל־sHash, פחות ממילישנייה ל־ORB.</a:t>
+            </a:r>
+          </a:p>
+          <a:p>
+            <a:r>
+              <a:t>השנייה — להשוות שתי תמונות. כאן ההבדל. [להצביע על הגרף] ל־sHash זה בערך עשירית מיקרו־שנייה — כמה ספירות ביטים. ל־ORB זה בערך 34 מילישניות — התאמת נקודות ציון ו־RANSAC, ארבע פעמים, בגלל גרסאות המראה. וגם כשמכווצים ל־128 נקודות — הנקודה האופטימלית מהשקף הקודם — זה עדיין 24 מילישניות.</a:t>
+            </a:r>
+          </a:p>
+          <a:p>
+            <a:r>
+              <a:t>לגבי הוגנות: השווינו קוד מקומפל מול קוד מקומפל — ה־C שלנו ל־sHash, שזהה ביט־בביט לספרייה, מול OpenCV. ספריית הפייתון שהמאמר השתמש בה, כמו שהיא, לוקחת 68 מילישניות ו־11 מיקרו־שניות — אבל היא מערבבת שפות, ולכן מדדנו גם את sHash ב־C.</a:t>
+            </a:r>
+          </a:p>
+          <a:p>
+            <a:r>
+              <a:t>המסקנה: עם 34 מילישניות לזוג, ORB צריך אינדקס כמו LSH כדי לגדול — וזה בדיוק מה שאחמד יראה.</a:t>
+            </a:r>
+          </a:p>
+          <a:p/>
+          <a:p>
+            <a:r>
+              <a:t>מעבר: „הנה איך ORB עובד בפועל — שלושה שלבים.”</a:t>
+            </a:r>
+          </a:p>
+        </p:txBody>
+      </p:sp>
+    </p:spTree>
+  </p:cSld>
+  <p:clrMapOvr>
+    <a:masterClrMapping/>
+  </p:clrMapOvr>
+</p:notes>
+</file>
+
 <file path=ppt/notesSlides/notesSlide3.xml><?xml version="1.0" encoding="utf-8"?>
 <p:notes xmlns:a="http://schemas.openxmlformats.org/drawingml/2006/main" xmlns:r="http://schemas.openxmlformats.org/officeDocument/2006/relationships" xmlns:p="http://schemas.openxmlformats.org/presentationml/2006/main">
   <p:cSld>
@@ -3268,7 +3341,7 @@
               <a:rPr lang="he-IL" sz="1400" dirty="0">
                 <a:cs typeface="Arial"/>
               </a:rPr>
-              <a:t>ב־ORB, כל נקודת ציון מתוארת ב־32 בתים, ולתמונה יש בערך 455 נקודות.</a:t>
+              <a:t>[להצביע על הגרף] הפס האפור הוא טרנזקציה שלמה אחת. sHash — היהלום הכתום — משמאל לו; כל העקומה הכחולה של ORB מימינו.</a:t>
             </a:r>
             <a:br>
               <a:rPr lang="he-IL" sz="1400" dirty="0"/>
@@ -3277,7 +3350,7 @@
               <a:rPr lang="he-IL" sz="1400" dirty="0">
                 <a:cs typeface="Arial"/>
               </a:rPr>
-              <a:t>זה כ־14,500 בתים — כמו 36 טרנזקציות שלמות.</a:t>
+              <a:t>ב־ORB, כל נקודת ציון מתוארת ב־32 בתים, ולתמונה יש בערך 455 נקודות.</a:t>
             </a:r>
             <a:br>
               <a:rPr lang="he-IL" sz="1400" dirty="0"/>
@@ -3286,7 +3359,7 @@
               <a:rPr lang="he-IL" sz="1400" dirty="0">
                 <a:cs typeface="Arial"/>
               </a:rPr>
-              <a:t>ניסינו לכווץ אותו:</a:t>
+              <a:t>זה כ־14,500 בתים — כמו 36 טרנזקציות שלמות.</a:t>
             </a:r>
             <a:br>
               <a:rPr lang="he-IL" sz="1400" dirty="0"/>
@@ -3295,7 +3368,7 @@
               <a:rPr lang="he-IL" sz="1400" dirty="0">
                 <a:cs typeface="Arial"/>
               </a:rPr>
-              <a:t>עם 128 נקודות זה כ־3,900 בתים — עדיין כמו 10 טרנזקציות — וה־F1 יורד רק מכ־91 ל־87.5.</a:t>
+              <a:t>ניסינו לכווץ אותו:</a:t>
             </a:r>
             <a:br>
               <a:rPr lang="he-IL" sz="1400" dirty="0"/>
@@ -3304,7 +3377,7 @@
               <a:rPr lang="he-IL" sz="1400" dirty="0">
                 <a:cs typeface="Arial"/>
               </a:rPr>
-              <a:t>עם 32 נקודות זה כ־1,000 בתים — בערך שתיים וחצי טרנזקציות — אבל ה־F1 יורד ל־76, בדיוק כמו sHash, שתופס רק 32 בתים.</a:t>
+              <a:t>עם 128 נקודות זה כ־3,900 בתים — עדיין כמו 10 טרנזקציות — וה־F1 יורד רק מכ־91 ל־87.5.</a:t>
             </a:r>
             <a:br>
               <a:rPr lang="he-IL" sz="1400" dirty="0"/>
@@ -3313,7 +3386,7 @@
               <a:rPr lang="he-IL" sz="1400" dirty="0">
                 <a:cs typeface="Arial"/>
               </a:rPr>
-              <a:t>כלומר, אין גודל שבו ORB גם נכנס לטרנזקציה וגם טוב יותר מ־sHash.</a:t>
+              <a:t>עם 32 נקודות זה כ־1,000 בתים — בערך שתיים וחצי טרנזקציות — אבל ה־F1 יורד ל־76, בדיוק כמו sHash, שתופס רק 32 בתים.</a:t>
             </a:r>
             <a:br>
               <a:rPr lang="he-IL" sz="1400" dirty="0"/>
@@ -3322,6 +3395,15 @@
               <a:rPr lang="he-IL" sz="1400" dirty="0">
                 <a:cs typeface="Arial"/>
               </a:rPr>
+              <a:t>כלומר, אין גודל שבו ORB גם נכנס לטרנזקציה וגם טוב יותר מ־sHash.</a:t>
+            </a:r>
+            <a:br>
+              <a:rPr lang="he-IL" sz="1400" dirty="0"/>
+            </a:br>
+            <a:r>
+              <a:rPr lang="he-IL" sz="1400" dirty="0">
+                <a:cs typeface="Arial"/>
+              </a:rPr>
               <a:t>זו מגבלה אמיתית של מה שבנינו, ואנחנו מציגים אותה כממצא.</a:t>
             </a:r>
           </a:p>
@@ -3335,7 +3417,7 @@
               <a:rPr lang="he-IL" sz="1400" dirty="0">
                 <a:cs typeface="Arial"/>
               </a:rPr>
-              <a:t>מעבר: „הנה איך ORB עובד בפועל — שלושה שלבים.”</a:t>
+              <a:t>מעבר: „זה המחיר במקום. ומה לגבי זמן?”</a:t>
             </a:r>
           </a:p>
         </p:txBody>
@@ -10678,6 +10760,376 @@
 </file>
 
 <file path=ppt/slides/slide10.xml><?xml version="1.0" encoding="utf-8"?>
+<p:sld xmlns:a="http://schemas.openxmlformats.org/drawingml/2006/main" xmlns:p="http://schemas.openxmlformats.org/presentationml/2006/main" xmlns:r="http://schemas.openxmlformats.org/officeDocument/2006/relationships">
+  <p:cSld>
+    <p:spTree>
+      <p:nvGrpSpPr>
+        <p:cNvPr id="1" name=""/>
+        <p:cNvGrpSpPr/>
+        <p:nvPr/>
+      </p:nvGrpSpPr>
+      <p:grpSpPr/>
+      <p:sp>
+        <p:nvSpPr>
+          <p:cNvPr id="2" name="Text 0"/>
+          <p:cNvSpPr txBox="1"/>
+          <p:nvPr/>
+        </p:nvSpPr>
+        <p:spPr>
+          <a:xfrm>
+            <a:off x="14977872" y="8595360"/>
+            <a:ext cx="548640" cy="320040"/>
+          </a:xfrm>
+          <a:prstGeom prst="rect">
+            <a:avLst/>
+          </a:prstGeom>
+          <a:noFill/>
+          <a:ln/>
+        </p:spPr>
+        <p:txBody>
+          <a:bodyPr wrap="square" lIns="0" tIns="0" rIns="0" bIns="0" rtlCol="0" anchor="ctr"/>
+          <a:lstStyle/>
+          <a:p>
+            <a:pPr marL="0" indent="0" algn="r">
+              <a:buNone/>
+            </a:pPr>
+            <a:r>
+              <a:rPr lang="en-US" sz="1100" dirty="0">
+                <a:solidFill>
+                  <a:srgbClr val="9AA0A6"/>
+                </a:solidFill>
+                <a:latin typeface="Arial" pitchFamily="34" charset="0"/>
+                <a:ea typeface="Arial" pitchFamily="34" charset="-122"/>
+                <a:cs typeface="Arial" pitchFamily="34" charset="-120"/>
+              </a:rPr>
+              <a:t>10</a:t>
+            </a:r>
+            <a:endParaRPr lang="en-US" sz="1100" dirty="0"/>
+          </a:p>
+        </p:txBody>
+      </p:sp>
+      <p:sp>
+        <p:nvSpPr>
+          <p:cNvPr id="3" name="Text 1"/>
+          <p:cNvSpPr txBox="1"/>
+          <p:nvPr/>
+        </p:nvSpPr>
+        <p:spPr>
+          <a:xfrm>
+            <a:off x="731520" y="502920"/>
+            <a:ext cx="14794992" cy="914400"/>
+          </a:xfrm>
+          <a:prstGeom prst="rect">
+            <a:avLst/>
+          </a:prstGeom>
+          <a:noFill/>
+          <a:ln/>
+        </p:spPr>
+        <p:txBody>
+          <a:bodyPr wrap="square" lIns="0" tIns="0" rIns="0" bIns="0" rtlCol="0" anchor="ctr"/>
+          <a:lstStyle/>
+          <a:p>
+            <a:pPr marL="0" indent="0">
+              <a:buNone/>
+            </a:pPr>
+            <a:r>
+              <a:rPr lang="en-US" sz="4400" dirty="0">
+                <a:solidFill>
+                  <a:srgbClr val="2B2B2B"/>
+                </a:solidFill>
+                <a:latin typeface="Arial" pitchFamily="34" charset="0"/>
+                <a:ea typeface="Arial" pitchFamily="34" charset="-122"/>
+                <a:cs typeface="Arial" pitchFamily="34" charset="-120"/>
+              </a:rPr>
+              <a:t>…and What It Costs in Time</a:t>
+            </a:r>
+            <a:endParaRPr lang="en-US" sz="4400" dirty="0"/>
+          </a:p>
+        </p:txBody>
+      </p:sp>
+      <p:sp>
+        <p:nvSpPr>
+          <p:cNvPr id="4" name="Text 2"/>
+          <p:cNvSpPr txBox="1"/>
+          <p:nvPr/>
+        </p:nvSpPr>
+        <p:spPr>
+          <a:xfrm>
+            <a:off x="731520" y="1325880"/>
+            <a:ext cx="14794992" cy="548640"/>
+          </a:xfrm>
+          <a:prstGeom prst="rect">
+            <a:avLst/>
+          </a:prstGeom>
+          <a:noFill/>
+          <a:ln/>
+        </p:spPr>
+        <p:txBody>
+          <a:bodyPr wrap="square" lIns="0" tIns="0" rIns="0" bIns="0" rtlCol="0" anchor="ctr"/>
+          <a:lstStyle/>
+          <a:p>
+            <a:pPr marL="0" indent="0">
+              <a:buNone/>
+            </a:pPr>
+            <a:r>
+              <a:rPr lang="en-US" sz="2000" dirty="0">
+                <a:solidFill>
+                  <a:srgbClr val="5F6368"/>
+                </a:solidFill>
+                <a:latin typeface="Arial" pitchFamily="34" charset="0"/>
+                <a:ea typeface="Arial" pitchFamily="34" charset="-122"/>
+                <a:cs typeface="Arial" pitchFamily="34" charset="-120"/>
+              </a:rPr>
+              <a:t>We timed the two jobs both signals do: fingerprint a new image, and compare two images.</a:t>
+            </a:r>
+            <a:endParaRPr lang="en-US" sz="2000" dirty="0"/>
+          </a:p>
+        </p:txBody>
+      </p:sp>
+      <p:sp>
+        <p:nvSpPr>
+          <p:cNvPr id="5" name="Text 3"/>
+          <p:cNvSpPr txBox="1"/>
+          <p:nvPr/>
+        </p:nvSpPr>
+        <p:spPr>
+          <a:xfrm>
+            <a:off x="731520" y="2286000"/>
+            <a:ext cx="6766560" cy="2377440"/>
+          </a:xfrm>
+          <a:prstGeom prst="rect">
+            <a:avLst/>
+          </a:prstGeom>
+          <a:noFill/>
+          <a:ln/>
+        </p:spPr>
+        <p:txBody>
+          <a:bodyPr wrap="square" lIns="0" tIns="0" rIns="0" bIns="0" rtlCol="0" anchor="t"/>
+          <a:lstStyle/>
+          <a:p>
+            <a:pPr marL="0" indent="0">
+              <a:spcAft>
+                <a:spcPts val="1400"/>
+              </a:spcAft>
+              <a:buNone/>
+            </a:pPr>
+            <a:r>
+              <a:rPr lang="en-US" sz="2400" b="1" dirty="0">
+                <a:solidFill>
+                  <a:srgbClr val="2B2B2B"/>
+                </a:solidFill>
+                <a:latin typeface="Arial" pitchFamily="34" charset="0"/>
+                <a:ea typeface="Arial" pitchFamily="34" charset="-122"/>
+                <a:cs typeface="Arial" pitchFamily="34" charset="-120"/>
+              </a:rPr>
+              <a:t>Making a fingerprint</a:t>
+            </a:r>
+            <a:endParaRPr lang="en-US" sz="1900" dirty="0"/>
+          </a:p>
+          <a:p>
+            <a:pPr marL="342900" indent="-342900">
+              <a:spcAft>
+                <a:spcPts val="1200"/>
+              </a:spcAft>
+              <a:buSzPct val="100000"/>
+              <a:buChar char="•"/>
+            </a:pPr>
+            <a:r>
+              <a:rPr lang="en-US" sz="1900" dirty="0">
+                <a:solidFill>
+                  <a:srgbClr val="2B2B2B"/>
+                </a:solidFill>
+                <a:latin typeface="Arial" pitchFamily="34" charset="0"/>
+                <a:ea typeface="Arial" pitchFamily="34" charset="-122"/>
+                <a:cs typeface="Arial" pitchFamily="34" charset="-120"/>
+              </a:rPr>
+              <a:t>About the same: ORB 0.9 ms (0.7 ms at 128 landmarks), sHash 1.5 ms.</a:t>
+            </a:r>
+            <a:endParaRPr lang="en-US" sz="1900" dirty="0"/>
+          </a:p>
+          <a:p>
+            <a:pPr marL="342900" indent="-342900">
+              <a:buSzPct val="100000"/>
+              <a:buChar char="•"/>
+            </a:pPr>
+            <a:r>
+              <a:rPr lang="en-US" sz="1900" dirty="0">
+                <a:solidFill>
+                  <a:srgbClr val="2B2B2B"/>
+                </a:solidFill>
+                <a:latin typeface="Arial" pitchFamily="34" charset="0"/>
+                <a:ea typeface="Arial" pitchFamily="34" charset="-122"/>
+                <a:cs typeface="Arial" pitchFamily="34" charset="-120"/>
+              </a:rPr>
+              <a:t>Both timed as compiled code, on one core.</a:t>
+            </a:r>
+            <a:endParaRPr lang="en-US" sz="1900" dirty="0"/>
+          </a:p>
+        </p:txBody>
+      </p:sp>
+      <p:sp>
+        <p:nvSpPr>
+          <p:cNvPr id="6" name="Text 4"/>
+          <p:cNvSpPr txBox="1"/>
+          <p:nvPr/>
+        </p:nvSpPr>
+        <p:spPr>
+          <a:xfrm>
+            <a:off x="731520" y="4937760"/>
+            <a:ext cx="6766560" cy="2011680"/>
+          </a:xfrm>
+          <a:prstGeom prst="rect">
+            <a:avLst/>
+          </a:prstGeom>
+          <a:noFill/>
+          <a:ln/>
+        </p:spPr>
+        <p:txBody>
+          <a:bodyPr wrap="square" lIns="0" tIns="0" rIns="0" bIns="0" rtlCol="0" anchor="t"/>
+          <a:lstStyle/>
+          <a:p>
+            <a:pPr marL="0" indent="0">
+              <a:spcAft>
+                <a:spcPts val="1200"/>
+              </a:spcAft>
+              <a:buNone/>
+            </a:pPr>
+            <a:r>
+              <a:rPr lang="en-US" sz="2400" b="1" dirty="0">
+                <a:solidFill>
+                  <a:srgbClr val="A33A47"/>
+                </a:solidFill>
+                <a:latin typeface="Arial" pitchFamily="34" charset="0"/>
+                <a:ea typeface="Arial" pitchFamily="34" charset="-122"/>
+                <a:cs typeface="Arial" pitchFamily="34" charset="-120"/>
+              </a:rPr>
+              <a:t>Comparing two images: the real gap</a:t>
+            </a:r>
+            <a:endParaRPr lang="en-US" sz="1900" dirty="0"/>
+          </a:p>
+          <a:p>
+            <a:pPr marL="0" indent="0">
+              <a:buNone/>
+            </a:pPr>
+            <a:r>
+              <a:rPr lang="en-US" sz="1900" dirty="0">
+                <a:solidFill>
+                  <a:srgbClr val="2B2B2B"/>
+                </a:solidFill>
+                <a:latin typeface="Arial" pitchFamily="34" charset="0"/>
+                <a:ea typeface="Arial" pitchFamily="34" charset="-122"/>
+                <a:cs typeface="Arial" pitchFamily="34" charset="-120"/>
+              </a:rPr>
+              <a:t>ORB ≈ 34 ms: match the landmarks, then RANSAC, for 4 mirror versions; still 24 ms at 128 landmarks. sHash ≈ 0.1 µs: a few bit counts.</a:t>
+            </a:r>
+            <a:endParaRPr lang="en-US" sz="1900" dirty="0"/>
+          </a:p>
+        </p:txBody>
+      </p:sp>
+      <p:sp>
+        <p:nvSpPr>
+          <p:cNvPr id="12" name="Shape 10"/>
+          <p:cNvSpPr/>
+          <p:nvPr/>
+        </p:nvSpPr>
+        <p:spPr>
+          <a:xfrm>
+            <a:off x="731520" y="7223760"/>
+            <a:ext cx="14794992" cy="1188720"/>
+          </a:xfrm>
+          <a:prstGeom prst="rect">
+            <a:avLst/>
+          </a:prstGeom>
+          <a:solidFill>
+            <a:srgbClr val="FFFFFF"/>
+          </a:solidFill>
+          <a:ln w="15875">
+            <a:solidFill>
+              <a:srgbClr val="2B2B2B"/>
+            </a:solidFill>
+            <a:prstDash val="solid"/>
+          </a:ln>
+        </p:spPr>
+        <p:txBody>
+          <a:bodyPr/>
+          <a:lstStyle/>
+          <a:p>
+            <a:endParaRPr lang="en-IL"/>
+          </a:p>
+        </p:txBody>
+      </p:sp>
+      <p:sp>
+        <p:nvSpPr>
+          <p:cNvPr id="13" name="Text 11"/>
+          <p:cNvSpPr txBox="1"/>
+          <p:nvPr/>
+        </p:nvSpPr>
+        <p:spPr>
+          <a:xfrm>
+            <a:off x="960120" y="7315200"/>
+            <a:ext cx="14337792" cy="1005840"/>
+          </a:xfrm>
+          <a:prstGeom prst="rect">
+            <a:avLst/>
+          </a:prstGeom>
+          <a:noFill/>
+          <a:ln/>
+        </p:spPr>
+        <p:txBody>
+          <a:bodyPr wrap="square" lIns="0" tIns="0" rIns="0" bIns="0" rtlCol="0" anchor="ctr"/>
+          <a:lstStyle/>
+          <a:p>
+            <a:pPr marL="0" indent="0" algn="ctr">
+              <a:buNone/>
+            </a:pPr>
+            <a:r>
+              <a:rPr lang="en-US" sz="1800" dirty="0">
+                <a:solidFill>
+                  <a:srgbClr val="2B2B2B"/>
+                </a:solidFill>
+                <a:latin typeface="Arial" pitchFamily="34" charset="0"/>
+                <a:ea typeface="Arial" pitchFamily="34" charset="-122"/>
+                <a:cs typeface="Arial" pitchFamily="34" charset="-120"/>
+              </a:rPr>
+              <a:t>Compiled code on both sides. The paper's Python library, as used, takes 68 ms and 11 µs: it mixes languages, so we timed sHash in C too. At ≈ 34 ms a pair, ORB needs an index (LSH) to scale.</a:t>
+            </a:r>
+            <a:endParaRPr lang="en-US" sz="1800" dirty="0"/>
+          </a:p>
+        </p:txBody>
+      </p:sp>
+      <p:pic>
+        <p:nvPicPr>
+          <p:cNvPr id="14" name="Time chart" descr="slide10_time_chart.png"/>
+          <p:cNvPicPr>
+            <a:picLocks noChangeAspect="1"/>
+          </p:cNvPicPr>
+          <p:nvPr/>
+        </p:nvPicPr>
+        <p:blipFill>
+          <a:blip r:embed="rId2"/>
+          <a:stretch>
+            <a:fillRect/>
+          </a:stretch>
+        </p:blipFill>
+        <p:spPr>
+          <a:xfrm>
+            <a:off x="8724710" y="2312739"/>
+            <a:ext cx="6443100" cy="4443063"/>
+          </a:xfrm>
+          <a:prstGeom prst="rect">
+            <a:avLst/>
+          </a:prstGeom>
+        </p:spPr>
+      </p:pic>
+    </p:spTree>
+  </p:cSld>
+  <p:clrMapOvr>
+    <a:masterClrMapping/>
+  </p:clrMapOvr>
+</p:sld>
+</file>
+
+<file path=ppt/slides/slide11.xml><?xml version="1.0" encoding="utf-8"?>
 <p:sld xmlns:a="http://schemas.openxmlformats.org/drawingml/2006/main" xmlns:r="http://schemas.openxmlformats.org/officeDocument/2006/relationships" xmlns:p="http://schemas.openxmlformats.org/presentationml/2006/main">
   <p:cSld>
     <p:bg>
@@ -10735,7 +11187,7 @@
                 <a:ea typeface="Arial" pitchFamily="34" charset="-122"/>
                 <a:cs typeface="Arial" pitchFamily="34" charset="-120"/>
               </a:rPr>
-              <a:t>10</a:t>
+              <a:t>11</a:t>
             </a:r>
             <a:endParaRPr lang="en-US" sz="1100" dirty="0"/>
           </a:p>
@@ -11637,7 +12089,7 @@
 </p:sld>
 </file>
 
-<file path=ppt/slides/slide11.xml><?xml version="1.0" encoding="utf-8"?>
+<file path=ppt/slides/slide12.xml><?xml version="1.0" encoding="utf-8"?>
 <p:sld xmlns:a="http://schemas.openxmlformats.org/drawingml/2006/main" xmlns:r="http://schemas.openxmlformats.org/officeDocument/2006/relationships" xmlns:p="http://schemas.openxmlformats.org/presentationml/2006/main">
   <p:cSld name="Slide 10">
     <p:bg>
@@ -11695,7 +12147,7 @@
                 <a:ea typeface="Arial" pitchFamily="34" charset="-122"/>
                 <a:cs typeface="Arial" pitchFamily="34" charset="-120"/>
               </a:rPr>
-              <a:t>11</a:t>
+              <a:t>12</a:t>
             </a:r>
             <a:endParaRPr lang="en-US" sz="1100" dirty="0"/>
           </a:p>
@@ -11950,7 +12402,7 @@
 </p:sld>
 </file>
 
-<file path=ppt/slides/slide12.xml><?xml version="1.0" encoding="utf-8"?>
+<file path=ppt/slides/slide13.xml><?xml version="1.0" encoding="utf-8"?>
 <p:sld xmlns:a="http://schemas.openxmlformats.org/drawingml/2006/main" xmlns:r="http://schemas.openxmlformats.org/officeDocument/2006/relationships" xmlns:p="http://schemas.openxmlformats.org/presentationml/2006/main">
   <p:cSld name="Slide 12">
     <p:bg>
@@ -12008,7 +12460,7 @@
                 <a:ea typeface="Arial" pitchFamily="34" charset="-122"/>
                 <a:cs typeface="Arial" pitchFamily="34" charset="-120"/>
               </a:rPr>
-              <a:t>12</a:t>
+              <a:t>13</a:t>
             </a:r>
             <a:endParaRPr lang="en-US" sz="1100" dirty="0"/>
           </a:p>
@@ -12830,7 +13282,7 @@
 </p:sld>
 </file>
 
-<file path=ppt/slides/slide13.xml><?xml version="1.0" encoding="utf-8"?>
+<file path=ppt/slides/slide14.xml><?xml version="1.0" encoding="utf-8"?>
 <p:sld xmlns:a="http://schemas.openxmlformats.org/drawingml/2006/main" xmlns:r="http://schemas.openxmlformats.org/officeDocument/2006/relationships" xmlns:p="http://schemas.openxmlformats.org/presentationml/2006/main">
   <p:cSld name="Slide 11">
     <p:bg>
@@ -12888,7 +13340,7 @@
                 <a:ea typeface="Arial" pitchFamily="34" charset="-122"/>
                 <a:cs typeface="Arial" pitchFamily="34" charset="-120"/>
               </a:rPr>
-              <a:t>13</a:t>
+              <a:t>14</a:t>
             </a:r>
             <a:endParaRPr lang="en-US" sz="1100" dirty="0"/>
           </a:p>
@@ -13143,7 +13595,7 @@
 </p:sld>
 </file>
 
-<file path=ppt/slides/slide14.xml><?xml version="1.0" encoding="utf-8"?>
+<file path=ppt/slides/slide15.xml><?xml version="1.0" encoding="utf-8"?>
 <p:sld xmlns:a="http://schemas.openxmlformats.org/drawingml/2006/main" xmlns:r="http://schemas.openxmlformats.org/officeDocument/2006/relationships" xmlns:p="http://schemas.openxmlformats.org/presentationml/2006/main">
   <p:cSld name="Slide 13">
     <p:bg>
@@ -13201,7 +13653,7 @@
                 <a:ea typeface="Arial" pitchFamily="34" charset="-122"/>
                 <a:cs typeface="Arial" pitchFamily="34" charset="-120"/>
               </a:rPr>
-              <a:t>14</a:t>
+              <a:t>15</a:t>
             </a:r>
             <a:endParaRPr lang="en-US" sz="1100" dirty="0"/>
           </a:p>
@@ -14389,7 +14841,7 @@
 </p:sld>
 </file>
 
-<file path=ppt/slides/slide15.xml><?xml version="1.0" encoding="utf-8"?>
+<file path=ppt/slides/slide16.xml><?xml version="1.0" encoding="utf-8"?>
 <p:sld xmlns:a="http://schemas.openxmlformats.org/drawingml/2006/main" xmlns:r="http://schemas.openxmlformats.org/officeDocument/2006/relationships" xmlns:p="http://schemas.openxmlformats.org/presentationml/2006/main">
   <p:cSld name="Slide 14">
     <p:bg>
@@ -14447,7 +14899,7 @@
                 <a:ea typeface="Arial" pitchFamily="34" charset="-122"/>
                 <a:cs typeface="Arial" pitchFamily="34" charset="-120"/>
               </a:rPr>
-              <a:t>15</a:t>
+              <a:t>16</a:t>
             </a:r>
             <a:endParaRPr lang="en-US" sz="1100" dirty="0"/>
           </a:p>
@@ -15495,7 +15947,7 @@
 </p:sld>
 </file>
 
-<file path=ppt/slides/slide16.xml><?xml version="1.0" encoding="utf-8"?>
+<file path=ppt/slides/slide17.xml><?xml version="1.0" encoding="utf-8"?>
 <p:sld xmlns:a="http://schemas.openxmlformats.org/drawingml/2006/main" xmlns:r="http://schemas.openxmlformats.org/officeDocument/2006/relationships" xmlns:p="http://schemas.openxmlformats.org/presentationml/2006/main">
   <p:cSld name="Slide 15">
     <p:bg>
@@ -15553,7 +16005,7 @@
                 <a:ea typeface="Arial" pitchFamily="34" charset="-122"/>
                 <a:cs typeface="Arial" pitchFamily="34" charset="-120"/>
               </a:rPr>
-              <a:t>16</a:t>
+              <a:t>17</a:t>
             </a:r>
             <a:endParaRPr lang="en-US" sz="1100" dirty="0"/>
           </a:p>
@@ -16632,7 +17084,7 @@
 </p:sld>
 </file>
 
-<file path=ppt/slides/slide17.xml><?xml version="1.0" encoding="utf-8"?>
+<file path=ppt/slides/slide18.xml><?xml version="1.0" encoding="utf-8"?>
 <p:sld xmlns:a="http://schemas.openxmlformats.org/drawingml/2006/main" xmlns:r="http://schemas.openxmlformats.org/officeDocument/2006/relationships" xmlns:p="http://schemas.openxmlformats.org/presentationml/2006/main">
   <p:cSld name="Slide 16">
     <p:bg>
@@ -16690,7 +17142,7 @@
                 <a:ea typeface="Arial" pitchFamily="34" charset="-122"/>
                 <a:cs typeface="Arial" pitchFamily="34" charset="-120"/>
               </a:rPr>
-              <a:t>17</a:t>
+              <a:t>18</a:t>
             </a:r>
             <a:endParaRPr lang="en-US" sz="1100" dirty="0"/>
           </a:p>
@@ -17014,7 +17466,7 @@
 </p:sld>
 </file>
 
-<file path=ppt/slides/slide18.xml><?xml version="1.0" encoding="utf-8"?>
+<file path=ppt/slides/slide19.xml><?xml version="1.0" encoding="utf-8"?>
 <p:sld xmlns:a="http://schemas.openxmlformats.org/drawingml/2006/main" xmlns:r="http://schemas.openxmlformats.org/officeDocument/2006/relationships" xmlns:p="http://schemas.openxmlformats.org/presentationml/2006/main">
   <p:cSld name="Slide 17">
     <p:bg>
@@ -17072,7 +17524,7 @@
                 <a:ea typeface="Arial" pitchFamily="34" charset="-122"/>
                 <a:cs typeface="Arial" pitchFamily="34" charset="-120"/>
               </a:rPr>
-              <a:t>18</a:t>
+              <a:t>19</a:t>
             </a:r>
             <a:endParaRPr lang="en-US" sz="1100" dirty="0"/>
           </a:p>
@@ -17575,471 +18027,6 @@
               <a:t>Our test set is mostly copies, so a detector that says "yes" to everything already scores well on F1. That's why the fair comparison is how many copies are caught at the same accusation rate: 64% → 77%.</a:t>
             </a:r>
             <a:endParaRPr lang="en-US" sz="2200" dirty="0"/>
-          </a:p>
-        </p:txBody>
-      </p:sp>
-    </p:spTree>
-  </p:cSld>
-  <p:clrMapOvr>
-    <a:masterClrMapping/>
-  </p:clrMapOvr>
-</p:sld>
-</file>
-
-<file path=ppt/slides/slide19.xml><?xml version="1.0" encoding="utf-8"?>
-<p:sld xmlns:a="http://schemas.openxmlformats.org/drawingml/2006/main" xmlns:r="http://schemas.openxmlformats.org/officeDocument/2006/relationships" xmlns:p="http://schemas.openxmlformats.org/presentationml/2006/main">
-  <p:cSld name="Slide 18">
-    <p:bg>
-      <p:bgPr>
-        <a:solidFill>
-          <a:srgbClr val="FAF5EA"/>
-        </a:solidFill>
-        <a:effectLst/>
-      </p:bgPr>
-    </p:bg>
-    <p:spTree>
-      <p:nvGrpSpPr>
-        <p:cNvPr id="1" name=""/>
-        <p:cNvGrpSpPr/>
-        <p:nvPr/>
-      </p:nvGrpSpPr>
-      <p:grpSpPr>
-        <a:xfrm>
-          <a:off x="0" y="0"/>
-          <a:ext cx="0" cy="0"/>
-          <a:chOff x="0" y="0"/>
-          <a:chExt cx="0" cy="0"/>
-        </a:xfrm>
-      </p:grpSpPr>
-      <p:sp>
-        <p:nvSpPr>
-          <p:cNvPr id="2" name="Text 0"/>
-          <p:cNvSpPr txBox="1"/>
-          <p:nvPr/>
-        </p:nvSpPr>
-        <p:spPr>
-          <a:xfrm>
-            <a:off x="14977872" y="8595360"/>
-            <a:ext cx="548640" cy="320040"/>
-          </a:xfrm>
-          <a:prstGeom prst="rect">
-            <a:avLst/>
-          </a:prstGeom>
-          <a:noFill/>
-          <a:ln/>
-        </p:spPr>
-        <p:txBody>
-          <a:bodyPr wrap="square" lIns="0" tIns="0" rIns="0" bIns="0" rtlCol="0" anchor="ctr"/>
-          <a:lstStyle/>
-          <a:p>
-            <a:pPr marL="0" indent="0" algn="r">
-              <a:buNone/>
-            </a:pPr>
-            <a:r>
-              <a:rPr lang="en-US" sz="1100" dirty="0">
-                <a:solidFill>
-                  <a:srgbClr val="9AA0A6"/>
-                </a:solidFill>
-                <a:latin typeface="Arial" pitchFamily="34" charset="0"/>
-                <a:ea typeface="Arial" pitchFamily="34" charset="-122"/>
-                <a:cs typeface="Arial" pitchFamily="34" charset="-120"/>
-              </a:rPr>
-              <a:t>19</a:t>
-            </a:r>
-            <a:endParaRPr lang="en-US" sz="1100" dirty="0"/>
-          </a:p>
-        </p:txBody>
-      </p:sp>
-      <p:sp>
-        <p:nvSpPr>
-          <p:cNvPr id="3" name="Text 1"/>
-          <p:cNvSpPr txBox="1"/>
-          <p:nvPr/>
-        </p:nvSpPr>
-        <p:spPr>
-          <a:xfrm>
-            <a:off x="731520" y="502920"/>
-            <a:ext cx="14794992" cy="914400"/>
-          </a:xfrm>
-          <a:prstGeom prst="rect">
-            <a:avLst/>
-          </a:prstGeom>
-          <a:noFill/>
-          <a:ln/>
-        </p:spPr>
-        <p:txBody>
-          <a:bodyPr wrap="square" lIns="0" tIns="0" rIns="0" bIns="0" rtlCol="0" anchor="ctr"/>
-          <a:lstStyle/>
-          <a:p>
-            <a:pPr marL="0" indent="0">
-              <a:buNone/>
-            </a:pPr>
-            <a:r>
-              <a:rPr lang="en-US" sz="4400" dirty="0">
-                <a:solidFill>
-                  <a:srgbClr val="2B2B2B"/>
-                </a:solidFill>
-                <a:latin typeface="Arial" pitchFamily="34" charset="0"/>
-                <a:ea typeface="Arial" pitchFamily="34" charset="-122"/>
-                <a:cs typeface="Arial" pitchFamily="34" charset="-120"/>
-              </a:rPr>
-              <a:t>What We Learned</a:t>
-            </a:r>
-            <a:endParaRPr lang="en-US" sz="4400" dirty="0"/>
-          </a:p>
-        </p:txBody>
-      </p:sp>
-      <p:sp>
-        <p:nvSpPr>
-          <p:cNvPr id="4" name="Text 2"/>
-          <p:cNvSpPr txBox="1"/>
-          <p:nvPr/>
-        </p:nvSpPr>
-        <p:spPr>
-          <a:xfrm>
-            <a:off x="731520" y="1783080"/>
-            <a:ext cx="1097280" cy="914400"/>
-          </a:xfrm>
-          <a:prstGeom prst="rect">
-            <a:avLst/>
-          </a:prstGeom>
-          <a:noFill/>
-          <a:ln/>
-        </p:spPr>
-        <p:txBody>
-          <a:bodyPr wrap="square" lIns="0" tIns="0" rIns="0" bIns="0" rtlCol="0" anchor="ctr"/>
-          <a:lstStyle/>
-          <a:p>
-            <a:pPr marL="0" indent="0">
-              <a:buNone/>
-            </a:pPr>
-            <a:r>
-              <a:rPr lang="en-US" sz="5200" b="1" dirty="0">
-                <a:solidFill>
-                  <a:srgbClr val="1A5FB4"/>
-                </a:solidFill>
-                <a:latin typeface="Arial" pitchFamily="34" charset="0"/>
-                <a:ea typeface="Arial" pitchFamily="34" charset="-122"/>
-                <a:cs typeface="Arial" pitchFamily="34" charset="-120"/>
-              </a:rPr>
-              <a:t>1.</a:t>
-            </a:r>
-            <a:endParaRPr lang="en-US" sz="5200" dirty="0"/>
-          </a:p>
-        </p:txBody>
-      </p:sp>
-      <p:sp>
-        <p:nvSpPr>
-          <p:cNvPr id="5" name="Text 3"/>
-          <p:cNvSpPr txBox="1"/>
-          <p:nvPr/>
-        </p:nvSpPr>
-        <p:spPr>
-          <a:xfrm>
-            <a:off x="1920240" y="1783080"/>
-            <a:ext cx="13606272" cy="1920240"/>
-          </a:xfrm>
-          <a:prstGeom prst="rect">
-            <a:avLst/>
-          </a:prstGeom>
-          <a:noFill/>
-          <a:ln/>
-        </p:spPr>
-        <p:txBody>
-          <a:bodyPr wrap="square" lIns="0" tIns="0" rIns="0" bIns="0" rtlCol="0" anchor="t"/>
-          <a:lstStyle/>
-          <a:p>
-            <a:pPr marL="0" indent="0">
-              <a:spcAft>
-                <a:spcPts val="800"/>
-              </a:spcAft>
-              <a:buNone/>
-            </a:pPr>
-            <a:r>
-              <a:rPr lang="en-US" sz="2500" b="1" dirty="0">
-                <a:solidFill>
-                  <a:srgbClr val="2B2B2B"/>
-                </a:solidFill>
-                <a:latin typeface="Arial" pitchFamily="34" charset="0"/>
-                <a:ea typeface="Arial" pitchFamily="34" charset="-122"/>
-                <a:cs typeface="Arial" pitchFamily="34" charset="-120"/>
-              </a:rPr>
-              <a:t>Check the maths before optimising it</a:t>
-            </a:r>
-            <a:endParaRPr lang="en-US" sz="2500" dirty="0"/>
-          </a:p>
-          <a:p>
-            <a:pPr marL="0" indent="0">
-              <a:buNone/>
-            </a:pPr>
-            <a:r>
-              <a:rPr lang="en-US" sz="1800" dirty="0">
-                <a:solidFill>
-                  <a:srgbClr val="2B2B2B"/>
-                </a:solidFill>
-                <a:latin typeface="Arial" pitchFamily="34" charset="0"/>
-                <a:ea typeface="Arial" pitchFamily="34" charset="-122"/>
-                <a:cs typeface="Arial" pitchFamily="34" charset="-120"/>
-              </a:rPr>
-              <a:t>We set out to make a search faster and found the search itself was unsound. Speed means nothing until the tool is correct.</a:t>
-            </a:r>
-            <a:endParaRPr lang="en-US" sz="2500" dirty="0"/>
-          </a:p>
-        </p:txBody>
-      </p:sp>
-      <p:sp>
-        <p:nvSpPr>
-          <p:cNvPr id="6" name="Shape 4"/>
-          <p:cNvSpPr/>
-          <p:nvPr/>
-        </p:nvSpPr>
-        <p:spPr>
-          <a:xfrm>
-            <a:off x="1920240" y="3749040"/>
-            <a:ext cx="13606272" cy="0"/>
-          </a:xfrm>
-          <a:prstGeom prst="line">
-            <a:avLst/>
-          </a:prstGeom>
-          <a:noFill/>
-          <a:ln w="12700">
-            <a:solidFill>
-              <a:srgbClr val="DEDBD3"/>
-            </a:solidFill>
-            <a:prstDash val="solid"/>
-          </a:ln>
-        </p:spPr>
-        <p:txBody>
-          <a:bodyPr/>
-          <a:lstStyle/>
-          <a:p>
-            <a:endParaRPr lang="en-IL"/>
-          </a:p>
-        </p:txBody>
-      </p:sp>
-      <p:sp>
-        <p:nvSpPr>
-          <p:cNvPr id="7" name="Text 5"/>
-          <p:cNvSpPr txBox="1"/>
-          <p:nvPr/>
-        </p:nvSpPr>
-        <p:spPr>
-          <a:xfrm>
-            <a:off x="731520" y="3931920"/>
-            <a:ext cx="1097280" cy="914400"/>
-          </a:xfrm>
-          <a:prstGeom prst="rect">
-            <a:avLst/>
-          </a:prstGeom>
-          <a:noFill/>
-          <a:ln/>
-        </p:spPr>
-        <p:txBody>
-          <a:bodyPr wrap="square" lIns="0" tIns="0" rIns="0" bIns="0" rtlCol="0" anchor="ctr"/>
-          <a:lstStyle/>
-          <a:p>
-            <a:pPr marL="0" indent="0">
-              <a:buNone/>
-            </a:pPr>
-            <a:r>
-              <a:rPr lang="en-US" sz="5200" b="1" dirty="0">
-                <a:solidFill>
-                  <a:srgbClr val="1A5FB4"/>
-                </a:solidFill>
-                <a:latin typeface="Arial" pitchFamily="34" charset="0"/>
-                <a:ea typeface="Arial" pitchFamily="34" charset="-122"/>
-                <a:cs typeface="Arial" pitchFamily="34" charset="-120"/>
-              </a:rPr>
-              <a:t>2.</a:t>
-            </a:r>
-            <a:endParaRPr lang="en-US" sz="5200" dirty="0"/>
-          </a:p>
-        </p:txBody>
-      </p:sp>
-      <p:sp>
-        <p:nvSpPr>
-          <p:cNvPr id="8" name="Text 6"/>
-          <p:cNvSpPr txBox="1"/>
-          <p:nvPr/>
-        </p:nvSpPr>
-        <p:spPr>
-          <a:xfrm>
-            <a:off x="1920240" y="3931920"/>
-            <a:ext cx="13606272" cy="1920240"/>
-          </a:xfrm>
-          <a:prstGeom prst="rect">
-            <a:avLst/>
-          </a:prstGeom>
-          <a:noFill/>
-          <a:ln/>
-        </p:spPr>
-        <p:txBody>
-          <a:bodyPr wrap="square" lIns="0" tIns="0" rIns="0" bIns="0" rtlCol="0" anchor="t"/>
-          <a:lstStyle/>
-          <a:p>
-            <a:pPr marL="0" indent="0">
-              <a:spcAft>
-                <a:spcPts val="800"/>
-              </a:spcAft>
-              <a:buNone/>
-            </a:pPr>
-            <a:r>
-              <a:rPr lang="en-US" sz="2500" b="1" dirty="0">
-                <a:solidFill>
-                  <a:srgbClr val="2B2B2B"/>
-                </a:solidFill>
-                <a:latin typeface="Arial" pitchFamily="34" charset="0"/>
-                <a:ea typeface="Arial" pitchFamily="34" charset="-122"/>
-                <a:cs typeface="Arial" pitchFamily="34" charset="-120"/>
-              </a:rPr>
-              <a:t>How you store a signal decides how you can search it</a:t>
-            </a:r>
-            <a:endParaRPr lang="en-US" sz="2500" dirty="0"/>
-          </a:p>
-          <a:p>
-            <a:pPr marL="0" indent="0">
-              <a:buNone/>
-            </a:pPr>
-            <a:r>
-              <a:rPr lang="en-US" sz="1800" dirty="0">
-                <a:solidFill>
-                  <a:srgbClr val="2B2B2B"/>
-                </a:solidFill>
-                <a:latin typeface="Arial" pitchFamily="34" charset="0"/>
-                <a:ea typeface="Arial" pitchFamily="34" charset="-122"/>
-                <a:cs typeface="Arial" pitchFamily="34" charset="-120"/>
-              </a:rPr>
-              <a:t>One fingerprint fits a tree. A set of landmarks needs a different index entirely. You don't get to pick the signal and the storage separately — that's what the 14.5 KB is really telling us.</a:t>
-            </a:r>
-            <a:endParaRPr lang="en-US" sz="2500" dirty="0"/>
-          </a:p>
-        </p:txBody>
-      </p:sp>
-      <p:sp>
-        <p:nvSpPr>
-          <p:cNvPr id="9" name="Shape 7"/>
-          <p:cNvSpPr/>
-          <p:nvPr/>
-        </p:nvSpPr>
-        <p:spPr>
-          <a:xfrm>
-            <a:off x="1920240" y="5897880"/>
-            <a:ext cx="13606272" cy="0"/>
-          </a:xfrm>
-          <a:prstGeom prst="line">
-            <a:avLst/>
-          </a:prstGeom>
-          <a:noFill/>
-          <a:ln w="12700">
-            <a:solidFill>
-              <a:srgbClr val="DEDBD3"/>
-            </a:solidFill>
-            <a:prstDash val="solid"/>
-          </a:ln>
-        </p:spPr>
-        <p:txBody>
-          <a:bodyPr/>
-          <a:lstStyle/>
-          <a:p>
-            <a:endParaRPr lang="en-IL"/>
-          </a:p>
-        </p:txBody>
-      </p:sp>
-      <p:sp>
-        <p:nvSpPr>
-          <p:cNvPr id="10" name="Text 8"/>
-          <p:cNvSpPr txBox="1"/>
-          <p:nvPr/>
-        </p:nvSpPr>
-        <p:spPr>
-          <a:xfrm>
-            <a:off x="731520" y="6080760"/>
-            <a:ext cx="1097280" cy="914400"/>
-          </a:xfrm>
-          <a:prstGeom prst="rect">
-            <a:avLst/>
-          </a:prstGeom>
-          <a:noFill/>
-          <a:ln/>
-        </p:spPr>
-        <p:txBody>
-          <a:bodyPr wrap="square" lIns="0" tIns="0" rIns="0" bIns="0" rtlCol="0" anchor="ctr"/>
-          <a:lstStyle/>
-          <a:p>
-            <a:pPr marL="0" indent="0">
-              <a:buNone/>
-            </a:pPr>
-            <a:r>
-              <a:rPr lang="en-US" sz="5200" b="1" dirty="0">
-                <a:solidFill>
-                  <a:srgbClr val="1A5FB4"/>
-                </a:solidFill>
-                <a:latin typeface="Arial" pitchFamily="34" charset="0"/>
-                <a:ea typeface="Arial" pitchFamily="34" charset="-122"/>
-                <a:cs typeface="Arial" pitchFamily="34" charset="-120"/>
-              </a:rPr>
-              <a:t>3.</a:t>
-            </a:r>
-            <a:endParaRPr lang="en-US" sz="5200" dirty="0"/>
-          </a:p>
-        </p:txBody>
-      </p:sp>
-      <p:sp>
-        <p:nvSpPr>
-          <p:cNvPr id="11" name="Text 9"/>
-          <p:cNvSpPr txBox="1"/>
-          <p:nvPr/>
-        </p:nvSpPr>
-        <p:spPr>
-          <a:xfrm>
-            <a:off x="1920240" y="6080760"/>
-            <a:ext cx="13606272" cy="1920240"/>
-          </a:xfrm>
-          <a:prstGeom prst="rect">
-            <a:avLst/>
-          </a:prstGeom>
-          <a:noFill/>
-          <a:ln/>
-        </p:spPr>
-        <p:txBody>
-          <a:bodyPr wrap="square" lIns="0" tIns="0" rIns="0" bIns="0" rtlCol="0" anchor="t"/>
-          <a:lstStyle/>
-          <a:p>
-            <a:pPr marL="0" indent="0">
-              <a:spcAft>
-                <a:spcPts val="800"/>
-              </a:spcAft>
-              <a:buNone/>
-            </a:pPr>
-            <a:r>
-              <a:rPr lang="en-US" sz="2500" b="1" dirty="0">
-                <a:solidFill>
-                  <a:srgbClr val="2B2B2B"/>
-                </a:solidFill>
-                <a:latin typeface="Arial" pitchFamily="34" charset="0"/>
-                <a:ea typeface="Arial" pitchFamily="34" charset="-122"/>
-                <a:cs typeface="Arial" pitchFamily="34" charset="-120"/>
-              </a:rPr>
-              <a:t>A negative result is still a result</a:t>
-            </a:r>
-            <a:endParaRPr lang="en-US" sz="2500" dirty="0"/>
-          </a:p>
-          <a:p>
-            <a:pPr marL="0" indent="0">
-              <a:buNone/>
-            </a:pPr>
-            <a:r>
-              <a:rPr lang="en-US" sz="1800" dirty="0">
-                <a:solidFill>
-                  <a:srgbClr val="2B2B2B"/>
-                </a:solidFill>
-                <a:latin typeface="Arial" pitchFamily="34" charset="0"/>
-                <a:ea typeface="Arial" pitchFamily="34" charset="-122"/>
-                <a:cs typeface="Arial" pitchFamily="34" charset="-120"/>
-              </a:rPr>
-              <a:t>We built the edit classifier, measured it, and it didn't improve accuracy — because a broken fingerprint here goes quiet rather than voting wrongly, so silencing it changes nothing. We're happy to go into the details.</a:t>
-            </a:r>
-            <a:endParaRPr lang="en-US" sz="2500" dirty="0"/>
           </a:p>
         </p:txBody>
       </p:sp>
@@ -18635,6 +18622,471 @@
 </file>
 
 <file path=ppt/slides/slide20.xml><?xml version="1.0" encoding="utf-8"?>
+<p:sld xmlns:a="http://schemas.openxmlformats.org/drawingml/2006/main" xmlns:r="http://schemas.openxmlformats.org/officeDocument/2006/relationships" xmlns:p="http://schemas.openxmlformats.org/presentationml/2006/main">
+  <p:cSld name="Slide 18">
+    <p:bg>
+      <p:bgPr>
+        <a:solidFill>
+          <a:srgbClr val="FAF5EA"/>
+        </a:solidFill>
+        <a:effectLst/>
+      </p:bgPr>
+    </p:bg>
+    <p:spTree>
+      <p:nvGrpSpPr>
+        <p:cNvPr id="1" name=""/>
+        <p:cNvGrpSpPr/>
+        <p:nvPr/>
+      </p:nvGrpSpPr>
+      <p:grpSpPr>
+        <a:xfrm>
+          <a:off x="0" y="0"/>
+          <a:ext cx="0" cy="0"/>
+          <a:chOff x="0" y="0"/>
+          <a:chExt cx="0" cy="0"/>
+        </a:xfrm>
+      </p:grpSpPr>
+      <p:sp>
+        <p:nvSpPr>
+          <p:cNvPr id="2" name="Text 0"/>
+          <p:cNvSpPr txBox="1"/>
+          <p:nvPr/>
+        </p:nvSpPr>
+        <p:spPr>
+          <a:xfrm>
+            <a:off x="14977872" y="8595360"/>
+            <a:ext cx="548640" cy="320040"/>
+          </a:xfrm>
+          <a:prstGeom prst="rect">
+            <a:avLst/>
+          </a:prstGeom>
+          <a:noFill/>
+          <a:ln/>
+        </p:spPr>
+        <p:txBody>
+          <a:bodyPr wrap="square" lIns="0" tIns="0" rIns="0" bIns="0" rtlCol="0" anchor="ctr"/>
+          <a:lstStyle/>
+          <a:p>
+            <a:pPr marL="0" indent="0" algn="r">
+              <a:buNone/>
+            </a:pPr>
+            <a:r>
+              <a:rPr lang="en-US" sz="1100" dirty="0">
+                <a:solidFill>
+                  <a:srgbClr val="9AA0A6"/>
+                </a:solidFill>
+                <a:latin typeface="Arial" pitchFamily="34" charset="0"/>
+                <a:ea typeface="Arial" pitchFamily="34" charset="-122"/>
+                <a:cs typeface="Arial" pitchFamily="34" charset="-120"/>
+              </a:rPr>
+              <a:t>20</a:t>
+            </a:r>
+            <a:endParaRPr lang="en-US" sz="1100" dirty="0"/>
+          </a:p>
+        </p:txBody>
+      </p:sp>
+      <p:sp>
+        <p:nvSpPr>
+          <p:cNvPr id="3" name="Text 1"/>
+          <p:cNvSpPr txBox="1"/>
+          <p:nvPr/>
+        </p:nvSpPr>
+        <p:spPr>
+          <a:xfrm>
+            <a:off x="731520" y="502920"/>
+            <a:ext cx="14794992" cy="914400"/>
+          </a:xfrm>
+          <a:prstGeom prst="rect">
+            <a:avLst/>
+          </a:prstGeom>
+          <a:noFill/>
+          <a:ln/>
+        </p:spPr>
+        <p:txBody>
+          <a:bodyPr wrap="square" lIns="0" tIns="0" rIns="0" bIns="0" rtlCol="0" anchor="ctr"/>
+          <a:lstStyle/>
+          <a:p>
+            <a:pPr marL="0" indent="0">
+              <a:buNone/>
+            </a:pPr>
+            <a:r>
+              <a:rPr lang="en-US" sz="4400" dirty="0">
+                <a:solidFill>
+                  <a:srgbClr val="2B2B2B"/>
+                </a:solidFill>
+                <a:latin typeface="Arial" pitchFamily="34" charset="0"/>
+                <a:ea typeface="Arial" pitchFamily="34" charset="-122"/>
+                <a:cs typeface="Arial" pitchFamily="34" charset="-120"/>
+              </a:rPr>
+              <a:t>What We Learned</a:t>
+            </a:r>
+            <a:endParaRPr lang="en-US" sz="4400" dirty="0"/>
+          </a:p>
+        </p:txBody>
+      </p:sp>
+      <p:sp>
+        <p:nvSpPr>
+          <p:cNvPr id="4" name="Text 2"/>
+          <p:cNvSpPr txBox="1"/>
+          <p:nvPr/>
+        </p:nvSpPr>
+        <p:spPr>
+          <a:xfrm>
+            <a:off x="731520" y="1783080"/>
+            <a:ext cx="1097280" cy="914400"/>
+          </a:xfrm>
+          <a:prstGeom prst="rect">
+            <a:avLst/>
+          </a:prstGeom>
+          <a:noFill/>
+          <a:ln/>
+        </p:spPr>
+        <p:txBody>
+          <a:bodyPr wrap="square" lIns="0" tIns="0" rIns="0" bIns="0" rtlCol="0" anchor="ctr"/>
+          <a:lstStyle/>
+          <a:p>
+            <a:pPr marL="0" indent="0">
+              <a:buNone/>
+            </a:pPr>
+            <a:r>
+              <a:rPr lang="en-US" sz="5200" b="1" dirty="0">
+                <a:solidFill>
+                  <a:srgbClr val="1A5FB4"/>
+                </a:solidFill>
+                <a:latin typeface="Arial" pitchFamily="34" charset="0"/>
+                <a:ea typeface="Arial" pitchFamily="34" charset="-122"/>
+                <a:cs typeface="Arial" pitchFamily="34" charset="-120"/>
+              </a:rPr>
+              <a:t>1.</a:t>
+            </a:r>
+            <a:endParaRPr lang="en-US" sz="5200" dirty="0"/>
+          </a:p>
+        </p:txBody>
+      </p:sp>
+      <p:sp>
+        <p:nvSpPr>
+          <p:cNvPr id="5" name="Text 3"/>
+          <p:cNvSpPr txBox="1"/>
+          <p:nvPr/>
+        </p:nvSpPr>
+        <p:spPr>
+          <a:xfrm>
+            <a:off x="1920240" y="1783080"/>
+            <a:ext cx="13606272" cy="1920240"/>
+          </a:xfrm>
+          <a:prstGeom prst="rect">
+            <a:avLst/>
+          </a:prstGeom>
+          <a:noFill/>
+          <a:ln/>
+        </p:spPr>
+        <p:txBody>
+          <a:bodyPr wrap="square" lIns="0" tIns="0" rIns="0" bIns="0" rtlCol="0" anchor="t"/>
+          <a:lstStyle/>
+          <a:p>
+            <a:pPr marL="0" indent="0">
+              <a:spcAft>
+                <a:spcPts val="800"/>
+              </a:spcAft>
+              <a:buNone/>
+            </a:pPr>
+            <a:r>
+              <a:rPr lang="en-US" sz="2500" b="1" dirty="0">
+                <a:solidFill>
+                  <a:srgbClr val="2B2B2B"/>
+                </a:solidFill>
+                <a:latin typeface="Arial" pitchFamily="34" charset="0"/>
+                <a:ea typeface="Arial" pitchFamily="34" charset="-122"/>
+                <a:cs typeface="Arial" pitchFamily="34" charset="-120"/>
+              </a:rPr>
+              <a:t>Check the maths before optimising it</a:t>
+            </a:r>
+            <a:endParaRPr lang="en-US" sz="2500" dirty="0"/>
+          </a:p>
+          <a:p>
+            <a:pPr marL="0" indent="0">
+              <a:buNone/>
+            </a:pPr>
+            <a:r>
+              <a:rPr lang="en-US" sz="1800" dirty="0">
+                <a:solidFill>
+                  <a:srgbClr val="2B2B2B"/>
+                </a:solidFill>
+                <a:latin typeface="Arial" pitchFamily="34" charset="0"/>
+                <a:ea typeface="Arial" pitchFamily="34" charset="-122"/>
+                <a:cs typeface="Arial" pitchFamily="34" charset="-120"/>
+              </a:rPr>
+              <a:t>We set out to make a search faster and found the search itself was unsound. Speed means nothing until the tool is correct.</a:t>
+            </a:r>
+            <a:endParaRPr lang="en-US" sz="2500" dirty="0"/>
+          </a:p>
+        </p:txBody>
+      </p:sp>
+      <p:sp>
+        <p:nvSpPr>
+          <p:cNvPr id="6" name="Shape 4"/>
+          <p:cNvSpPr/>
+          <p:nvPr/>
+        </p:nvSpPr>
+        <p:spPr>
+          <a:xfrm>
+            <a:off x="1920240" y="3749040"/>
+            <a:ext cx="13606272" cy="0"/>
+          </a:xfrm>
+          <a:prstGeom prst="line">
+            <a:avLst/>
+          </a:prstGeom>
+          <a:noFill/>
+          <a:ln w="12700">
+            <a:solidFill>
+              <a:srgbClr val="DEDBD3"/>
+            </a:solidFill>
+            <a:prstDash val="solid"/>
+          </a:ln>
+        </p:spPr>
+        <p:txBody>
+          <a:bodyPr/>
+          <a:lstStyle/>
+          <a:p>
+            <a:endParaRPr lang="en-IL"/>
+          </a:p>
+        </p:txBody>
+      </p:sp>
+      <p:sp>
+        <p:nvSpPr>
+          <p:cNvPr id="7" name="Text 5"/>
+          <p:cNvSpPr txBox="1"/>
+          <p:nvPr/>
+        </p:nvSpPr>
+        <p:spPr>
+          <a:xfrm>
+            <a:off x="731520" y="3931920"/>
+            <a:ext cx="1097280" cy="914400"/>
+          </a:xfrm>
+          <a:prstGeom prst="rect">
+            <a:avLst/>
+          </a:prstGeom>
+          <a:noFill/>
+          <a:ln/>
+        </p:spPr>
+        <p:txBody>
+          <a:bodyPr wrap="square" lIns="0" tIns="0" rIns="0" bIns="0" rtlCol="0" anchor="ctr"/>
+          <a:lstStyle/>
+          <a:p>
+            <a:pPr marL="0" indent="0">
+              <a:buNone/>
+            </a:pPr>
+            <a:r>
+              <a:rPr lang="en-US" sz="5200" b="1" dirty="0">
+                <a:solidFill>
+                  <a:srgbClr val="1A5FB4"/>
+                </a:solidFill>
+                <a:latin typeface="Arial" pitchFamily="34" charset="0"/>
+                <a:ea typeface="Arial" pitchFamily="34" charset="-122"/>
+                <a:cs typeface="Arial" pitchFamily="34" charset="-120"/>
+              </a:rPr>
+              <a:t>2.</a:t>
+            </a:r>
+            <a:endParaRPr lang="en-US" sz="5200" dirty="0"/>
+          </a:p>
+        </p:txBody>
+      </p:sp>
+      <p:sp>
+        <p:nvSpPr>
+          <p:cNvPr id="8" name="Text 6"/>
+          <p:cNvSpPr txBox="1"/>
+          <p:nvPr/>
+        </p:nvSpPr>
+        <p:spPr>
+          <a:xfrm>
+            <a:off x="1920240" y="3931920"/>
+            <a:ext cx="13606272" cy="1920240"/>
+          </a:xfrm>
+          <a:prstGeom prst="rect">
+            <a:avLst/>
+          </a:prstGeom>
+          <a:noFill/>
+          <a:ln/>
+        </p:spPr>
+        <p:txBody>
+          <a:bodyPr wrap="square" lIns="0" tIns="0" rIns="0" bIns="0" rtlCol="0" anchor="t"/>
+          <a:lstStyle/>
+          <a:p>
+            <a:pPr marL="0" indent="0">
+              <a:spcAft>
+                <a:spcPts val="800"/>
+              </a:spcAft>
+              <a:buNone/>
+            </a:pPr>
+            <a:r>
+              <a:rPr lang="en-US" sz="2500" b="1" dirty="0">
+                <a:solidFill>
+                  <a:srgbClr val="2B2B2B"/>
+                </a:solidFill>
+                <a:latin typeface="Arial" pitchFamily="34" charset="0"/>
+                <a:ea typeface="Arial" pitchFamily="34" charset="-122"/>
+                <a:cs typeface="Arial" pitchFamily="34" charset="-120"/>
+              </a:rPr>
+              <a:t>How you store a signal decides how you can search it</a:t>
+            </a:r>
+            <a:endParaRPr lang="en-US" sz="2500" dirty="0"/>
+          </a:p>
+          <a:p>
+            <a:pPr marL="0" indent="0">
+              <a:buNone/>
+            </a:pPr>
+            <a:r>
+              <a:rPr lang="en-US" sz="1800" dirty="0">
+                <a:solidFill>
+                  <a:srgbClr val="2B2B2B"/>
+                </a:solidFill>
+                <a:latin typeface="Arial" pitchFamily="34" charset="0"/>
+                <a:ea typeface="Arial" pitchFamily="34" charset="-122"/>
+                <a:cs typeface="Arial" pitchFamily="34" charset="-120"/>
+              </a:rPr>
+              <a:t>One fingerprint fits a tree. A set of landmarks needs a different index entirely. You don't get to pick the signal and the storage separately — that's what the 14.5 KB is really telling us.</a:t>
+            </a:r>
+            <a:endParaRPr lang="en-US" sz="2500" dirty="0"/>
+          </a:p>
+        </p:txBody>
+      </p:sp>
+      <p:sp>
+        <p:nvSpPr>
+          <p:cNvPr id="9" name="Shape 7"/>
+          <p:cNvSpPr/>
+          <p:nvPr/>
+        </p:nvSpPr>
+        <p:spPr>
+          <a:xfrm>
+            <a:off x="1920240" y="5897880"/>
+            <a:ext cx="13606272" cy="0"/>
+          </a:xfrm>
+          <a:prstGeom prst="line">
+            <a:avLst/>
+          </a:prstGeom>
+          <a:noFill/>
+          <a:ln w="12700">
+            <a:solidFill>
+              <a:srgbClr val="DEDBD3"/>
+            </a:solidFill>
+            <a:prstDash val="solid"/>
+          </a:ln>
+        </p:spPr>
+        <p:txBody>
+          <a:bodyPr/>
+          <a:lstStyle/>
+          <a:p>
+            <a:endParaRPr lang="en-IL"/>
+          </a:p>
+        </p:txBody>
+      </p:sp>
+      <p:sp>
+        <p:nvSpPr>
+          <p:cNvPr id="10" name="Text 8"/>
+          <p:cNvSpPr txBox="1"/>
+          <p:nvPr/>
+        </p:nvSpPr>
+        <p:spPr>
+          <a:xfrm>
+            <a:off x="731520" y="6080760"/>
+            <a:ext cx="1097280" cy="914400"/>
+          </a:xfrm>
+          <a:prstGeom prst="rect">
+            <a:avLst/>
+          </a:prstGeom>
+          <a:noFill/>
+          <a:ln/>
+        </p:spPr>
+        <p:txBody>
+          <a:bodyPr wrap="square" lIns="0" tIns="0" rIns="0" bIns="0" rtlCol="0" anchor="ctr"/>
+          <a:lstStyle/>
+          <a:p>
+            <a:pPr marL="0" indent="0">
+              <a:buNone/>
+            </a:pPr>
+            <a:r>
+              <a:rPr lang="en-US" sz="5200" b="1" dirty="0">
+                <a:solidFill>
+                  <a:srgbClr val="1A5FB4"/>
+                </a:solidFill>
+                <a:latin typeface="Arial" pitchFamily="34" charset="0"/>
+                <a:ea typeface="Arial" pitchFamily="34" charset="-122"/>
+                <a:cs typeface="Arial" pitchFamily="34" charset="-120"/>
+              </a:rPr>
+              <a:t>3.</a:t>
+            </a:r>
+            <a:endParaRPr lang="en-US" sz="5200" dirty="0"/>
+          </a:p>
+        </p:txBody>
+      </p:sp>
+      <p:sp>
+        <p:nvSpPr>
+          <p:cNvPr id="11" name="Text 9"/>
+          <p:cNvSpPr txBox="1"/>
+          <p:nvPr/>
+        </p:nvSpPr>
+        <p:spPr>
+          <a:xfrm>
+            <a:off x="1920240" y="6080760"/>
+            <a:ext cx="13606272" cy="1920240"/>
+          </a:xfrm>
+          <a:prstGeom prst="rect">
+            <a:avLst/>
+          </a:prstGeom>
+          <a:noFill/>
+          <a:ln/>
+        </p:spPr>
+        <p:txBody>
+          <a:bodyPr wrap="square" lIns="0" tIns="0" rIns="0" bIns="0" rtlCol="0" anchor="t"/>
+          <a:lstStyle/>
+          <a:p>
+            <a:pPr marL="0" indent="0">
+              <a:spcAft>
+                <a:spcPts val="800"/>
+              </a:spcAft>
+              <a:buNone/>
+            </a:pPr>
+            <a:r>
+              <a:rPr lang="en-US" sz="2500" b="1" dirty="0">
+                <a:solidFill>
+                  <a:srgbClr val="2B2B2B"/>
+                </a:solidFill>
+                <a:latin typeface="Arial" pitchFamily="34" charset="0"/>
+                <a:ea typeface="Arial" pitchFamily="34" charset="-122"/>
+                <a:cs typeface="Arial" pitchFamily="34" charset="-120"/>
+              </a:rPr>
+              <a:t>A negative result is still a result</a:t>
+            </a:r>
+            <a:endParaRPr lang="en-US" sz="2500" dirty="0"/>
+          </a:p>
+          <a:p>
+            <a:pPr marL="0" indent="0">
+              <a:buNone/>
+            </a:pPr>
+            <a:r>
+              <a:rPr lang="en-US" sz="1800" dirty="0">
+                <a:solidFill>
+                  <a:srgbClr val="2B2B2B"/>
+                </a:solidFill>
+                <a:latin typeface="Arial" pitchFamily="34" charset="0"/>
+                <a:ea typeface="Arial" pitchFamily="34" charset="-122"/>
+                <a:cs typeface="Arial" pitchFamily="34" charset="-120"/>
+              </a:rPr>
+              <a:t>We built the edit classifier, measured it, and it didn't improve accuracy — because a broken fingerprint here goes quiet rather than voting wrongly, so silencing it changes nothing. We're happy to go into the details.</a:t>
+            </a:r>
+            <a:endParaRPr lang="en-US" sz="2500" dirty="0"/>
+          </a:p>
+        </p:txBody>
+      </p:sp>
+    </p:spTree>
+  </p:cSld>
+  <p:clrMapOvr>
+    <a:masterClrMapping/>
+  </p:clrMapOvr>
+</p:sld>
+</file>
+
+<file path=ppt/slides/slide21.xml><?xml version="1.0" encoding="utf-8"?>
 <p:sld xmlns:a="http://schemas.openxmlformats.org/drawingml/2006/main" xmlns:r="http://schemas.openxmlformats.org/officeDocument/2006/relationships" xmlns:p="http://schemas.openxmlformats.org/presentationml/2006/main" show="0">
   <p:cSld name="Slide 19">
     <p:bg>
@@ -18692,7 +19144,7 @@
                 <a:ea typeface="Arial" pitchFamily="34" charset="-122"/>
                 <a:cs typeface="Arial" pitchFamily="34" charset="-120"/>
               </a:rPr>
-              <a:t>20</a:t>
+              <a:t>21</a:t>
             </a:r>
             <a:endParaRPr lang="en-US" sz="1100" dirty="0"/>
           </a:p>
@@ -19057,7 +19509,7 @@
 </p:sld>
 </file>
 
-<file path=ppt/slides/slide21.xml><?xml version="1.0" encoding="utf-8"?>
+<file path=ppt/slides/slide22.xml><?xml version="1.0" encoding="utf-8"?>
 <p:sld xmlns:a="http://schemas.openxmlformats.org/drawingml/2006/main" xmlns:r="http://schemas.openxmlformats.org/officeDocument/2006/relationships" xmlns:p="http://schemas.openxmlformats.org/presentationml/2006/main">
   <p:cSld name="Slide 20">
     <p:bg>
@@ -19115,7 +19567,7 @@
                 <a:ea typeface="Arial" pitchFamily="34" charset="-122"/>
                 <a:cs typeface="Arial" pitchFamily="34" charset="-120"/>
               </a:rPr>
-              <a:t>21</a:t>
+              <a:t>22</a:t>
             </a:r>
             <a:endParaRPr lang="en-US" sz="1100" dirty="0"/>
           </a:p>
@@ -19599,7 +20051,7 @@
                 <a:ea typeface="Arial" pitchFamily="34" charset="-122"/>
                 <a:cs typeface="Arial" pitchFamily="34" charset="-120"/>
               </a:rPr>
-              <a:t>   —   +14.2 on the job it was built for, +8.9 in the full system — but too big to store on-chain</a:t>
+              <a:t>   —   +14.2 on the job it was built for, +8.9 in the full system — but too big to store on-chain, ≈ 34 ms a pair</a:t>
             </a:r>
             <a:endParaRPr lang="en-US" sz="2600" dirty="0"/>
           </a:p>
@@ -19652,7 +20104,7 @@
 </p:sld>
 </file>
 
-<file path=ppt/slides/slide22.xml><?xml version="1.0" encoding="utf-8"?>
+<file path=ppt/slides/slide23.xml><?xml version="1.0" encoding="utf-8"?>
 <p:sld xmlns:a="http://schemas.openxmlformats.org/drawingml/2006/main" xmlns:r="http://schemas.openxmlformats.org/officeDocument/2006/relationships" xmlns:p="http://schemas.openxmlformats.org/presentationml/2006/main" show="0">
   <p:cSld name="Slide 21">
     <p:bg>
@@ -19710,7 +20162,7 @@
                 <a:ea typeface="Arial" pitchFamily="34" charset="-122"/>
                 <a:cs typeface="Arial" pitchFamily="34" charset="-120"/>
               </a:rPr>
-              <a:t>22</a:t>
+              <a:t>23</a:t>
             </a:r>
             <a:endParaRPr lang="en-US" sz="1100" dirty="0"/>
           </a:p>
@@ -19879,7 +20331,7 @@
                 <a:ea typeface="Arial" pitchFamily="34" charset="-122"/>
                 <a:cs typeface="Arial" pitchFamily="34" charset="-120"/>
               </a:rPr>
-              <a:t>ORB against sHash, head to head   ·   slide 15</a:t>
+              <a:t>ORB against sHash, head to head   ·   slide 17</a:t>
             </a:r>
             <a:endParaRPr lang="en-US" sz="1900" dirty="0"/>
           </a:p>
@@ -20061,7 +20513,7 @@
                 <a:ea typeface="Arial" pitchFamily="34" charset="-122"/>
                 <a:cs typeface="Arial" pitchFamily="34" charset="-120"/>
               </a:rPr>
-              <a:t>the paper at its own thresholds, against our swap   ·   slide 17</a:t>
+              <a:t>the paper at its own thresholds, against our swap   ·   slide 19</a:t>
             </a:r>
             <a:endParaRPr lang="en-US" sz="1900" dirty="0"/>
           </a:p>
@@ -25961,269 +26413,30 @@
           </a:p>
         </p:txBody>
       </p:sp>
-      <p:sp>
-        <p:nvSpPr>
-          <p:cNvPr id="7" name="Shape 5"/>
-          <p:cNvSpPr/>
-          <p:nvPr/>
-        </p:nvSpPr>
-        <p:spPr>
-          <a:xfrm>
-            <a:off x="8412480" y="2377440"/>
-            <a:ext cx="274320" cy="274320"/>
-          </a:xfrm>
-          <a:prstGeom prst="rect">
-            <a:avLst/>
-          </a:prstGeom>
-          <a:solidFill>
-            <a:srgbClr val="9AA0A6"/>
-          </a:solidFill>
-          <a:ln w="12700">
-            <a:solidFill>
-              <a:srgbClr val="2B2B2B"/>
-            </a:solidFill>
-            <a:prstDash val="solid"/>
-          </a:ln>
-        </p:spPr>
-        <p:txBody>
-          <a:bodyPr/>
-          <a:lstStyle/>
-          <a:p>
-            <a:endParaRPr lang="en-IL"/>
-          </a:p>
-        </p:txBody>
-      </p:sp>
-      <p:sp>
-        <p:nvSpPr>
-          <p:cNvPr id="8" name="Text 6"/>
-          <p:cNvSpPr txBox="1"/>
-          <p:nvPr/>
-        </p:nvSpPr>
-        <p:spPr>
-          <a:xfrm>
-            <a:off x="8915400" y="2286000"/>
-            <a:ext cx="6611112" cy="457200"/>
-          </a:xfrm>
-          <a:prstGeom prst="rect">
-            <a:avLst/>
-          </a:prstGeom>
-          <a:noFill/>
-          <a:ln/>
-        </p:spPr>
-        <p:txBody>
-          <a:bodyPr wrap="square" lIns="0" tIns="0" rIns="0" bIns="0" rtlCol="0" anchor="ctr"/>
-          <a:lstStyle/>
-          <a:p>
-            <a:pPr marL="0" indent="0">
-              <a:buNone/>
-            </a:pPr>
-            <a:r>
-              <a:rPr lang="en-US" sz="1800" dirty="0">
-                <a:solidFill>
-                  <a:srgbClr val="2B2B2B"/>
-                </a:solidFill>
-                <a:latin typeface="Arial" pitchFamily="34" charset="0"/>
-                <a:ea typeface="Arial" pitchFamily="34" charset="-122"/>
-                <a:cs typeface="Arial" pitchFamily="34" charset="-120"/>
-              </a:rPr>
-              <a:t>the four fingerprints:  ≈ 56 bytes</a:t>
-            </a:r>
-            <a:endParaRPr lang="en-US" sz="1800" dirty="0"/>
-          </a:p>
-        </p:txBody>
-      </p:sp>
-      <p:sp>
-        <p:nvSpPr>
-          <p:cNvPr id="14" name="Shape 12"/>
-          <p:cNvSpPr/>
-          <p:nvPr/>
-        </p:nvSpPr>
-        <p:spPr>
-          <a:xfrm>
-            <a:off x="8366760" y="2880360"/>
-            <a:ext cx="365760" cy="365760"/>
-          </a:xfrm>
-          <a:prstGeom prst="rect">
-            <a:avLst/>
-          </a:prstGeom>
-          <a:solidFill>
-            <a:srgbClr val="C9D6EA"/>
-          </a:solidFill>
-          <a:ln w="12700">
-            <a:solidFill>
-              <a:srgbClr val="2B2B2B"/>
-            </a:solidFill>
-            <a:prstDash val="solid"/>
-          </a:ln>
-        </p:spPr>
-        <p:txBody>
-          <a:bodyPr/>
-          <a:lstStyle/>
-          <a:p>
-            <a:endParaRPr lang="en-IL"/>
-          </a:p>
-        </p:txBody>
-      </p:sp>
-      <p:sp>
-        <p:nvSpPr>
-          <p:cNvPr id="15" name="Text 13"/>
-          <p:cNvSpPr txBox="1"/>
-          <p:nvPr/>
-        </p:nvSpPr>
-        <p:spPr>
-          <a:xfrm>
-            <a:off x="8915400" y="2834640"/>
-            <a:ext cx="6611112" cy="457200"/>
-          </a:xfrm>
-          <a:prstGeom prst="rect">
-            <a:avLst/>
-          </a:prstGeom>
-          <a:noFill/>
-          <a:ln/>
-        </p:spPr>
-        <p:txBody>
-          <a:bodyPr wrap="square" lIns="0" tIns="0" rIns="0" bIns="0" rtlCol="0" anchor="ctr"/>
-          <a:lstStyle/>
-          <a:p>
-            <a:pPr marL="0" indent="0">
-              <a:buNone/>
-            </a:pPr>
-            <a:r>
-              <a:rPr lang="en-US" sz="1800" dirty="0">
-                <a:solidFill>
-                  <a:srgbClr val="2B2B2B"/>
-                </a:solidFill>
-                <a:latin typeface="Arial" pitchFamily="34" charset="0"/>
-                <a:ea typeface="Arial" pitchFamily="34" charset="-122"/>
-                <a:cs typeface="Arial" pitchFamily="34" charset="-120"/>
-              </a:rPr>
-              <a:t>a whole mint transaction:  300–500 bytes</a:t>
-            </a:r>
-            <a:r>
-              <a:rPr lang="en-US" sz="1400" dirty="0">
-                <a:solidFill>
-                  <a:srgbClr val="5F6368"/>
-                </a:solidFill>
-                <a:latin typeface="Arial" pitchFamily="34" charset="0"/>
-                <a:ea typeface="Arial" pitchFamily="34" charset="-122"/>
-                <a:cs typeface="Arial" pitchFamily="34" charset="-120"/>
-              </a:rPr>
-              <a:t>   (the paper)</a:t>
-            </a:r>
-            <a:endParaRPr lang="en-US" sz="1800" dirty="0"/>
-          </a:p>
-        </p:txBody>
-      </p:sp>
-      <p:sp>
-        <p:nvSpPr>
-          <p:cNvPr id="9" name="Shape 7"/>
-          <p:cNvSpPr/>
-          <p:nvPr/>
-        </p:nvSpPr>
-        <p:spPr>
-          <a:xfrm>
-            <a:off x="8412480" y="3566160"/>
-            <a:ext cx="6400800" cy="2560320"/>
-          </a:xfrm>
-          <a:prstGeom prst="rect">
-            <a:avLst/>
-          </a:prstGeom>
-          <a:solidFill>
-            <a:srgbClr val="1A5FB4"/>
-          </a:solidFill>
-          <a:ln w="12700">
-            <a:solidFill>
-              <a:srgbClr val="1A5FB4"/>
-            </a:solidFill>
-            <a:prstDash val="solid"/>
-          </a:ln>
-        </p:spPr>
-        <p:txBody>
-          <a:bodyPr/>
-          <a:lstStyle/>
-          <a:p>
-            <a:endParaRPr lang="en-IL"/>
-          </a:p>
-        </p:txBody>
-      </p:sp>
-      <p:sp>
-        <p:nvSpPr>
-          <p:cNvPr id="10" name="Text 8"/>
-          <p:cNvSpPr txBox="1"/>
-          <p:nvPr/>
-        </p:nvSpPr>
-        <p:spPr>
-          <a:xfrm>
-            <a:off x="8412480" y="4480560"/>
-            <a:ext cx="6400800" cy="731520"/>
-          </a:xfrm>
-          <a:prstGeom prst="rect">
-            <a:avLst/>
-          </a:prstGeom>
-          <a:noFill/>
-          <a:ln/>
-        </p:spPr>
-        <p:txBody>
-          <a:bodyPr wrap="square" lIns="0" tIns="0" rIns="0" bIns="0" rtlCol="0" anchor="ctr"/>
-          <a:lstStyle/>
-          <a:p>
-            <a:pPr marL="0" indent="0" algn="ctr">
-              <a:buNone/>
-            </a:pPr>
-            <a:r>
-              <a:rPr lang="en-US" sz="3000" b="1" dirty="0">
-                <a:solidFill>
-                  <a:srgbClr val="FFFFFF"/>
-                </a:solidFill>
-                <a:latin typeface="Courier New" pitchFamily="34" charset="0"/>
-                <a:ea typeface="Courier New" pitchFamily="34" charset="-122"/>
-                <a:cs typeface="Courier New" pitchFamily="34" charset="-120"/>
-              </a:rPr>
-              <a:t>ORB:  14,560 bytes</a:t>
-            </a:r>
-            <a:endParaRPr lang="en-US" sz="3000" dirty="0"/>
-          </a:p>
-        </p:txBody>
-      </p:sp>
-      <p:sp>
-        <p:nvSpPr>
-          <p:cNvPr id="11" name="Text 9"/>
-          <p:cNvSpPr txBox="1"/>
-          <p:nvPr/>
-        </p:nvSpPr>
-        <p:spPr>
-          <a:xfrm>
-            <a:off x="8412480" y="6263640"/>
-            <a:ext cx="6400800" cy="457200"/>
-          </a:xfrm>
-          <a:prstGeom prst="rect">
-            <a:avLst/>
-          </a:prstGeom>
-          <a:noFill/>
-          <a:ln/>
-        </p:spPr>
-        <p:txBody>
-          <a:bodyPr wrap="square" lIns="0" tIns="0" rIns="0" bIns="0" rtlCol="0" anchor="ctr"/>
-          <a:lstStyle/>
-          <a:p>
-            <a:pPr marL="0" indent="0" algn="ctr">
-              <a:buNone/>
-            </a:pPr>
-            <a:r>
-              <a:rPr lang="en-US" sz="1600" dirty="0">
-                <a:solidFill>
-                  <a:srgbClr val="5F6368"/>
-                </a:solidFill>
-                <a:latin typeface="Arial" pitchFamily="34" charset="0"/>
-                <a:ea typeface="Arial" pitchFamily="34" charset="-122"/>
-                <a:cs typeface="Arial" pitchFamily="34" charset="-120"/>
-              </a:rPr>
-              <a:t>≈ 36 whole transactions, for one image     (not to scale)</a:t>
-            </a:r>
-            <a:endParaRPr lang="en-US" sz="1600" dirty="0"/>
-          </a:p>
-        </p:txBody>
-      </p:sp>
+      <p:pic>
+        <p:nvPicPr>
+          <p:cNvPr id="20" name="Storage chart" descr="F1 versus bytes stored per image: sHash at about 32 bytes, one mint transaction at 300 to 500 bytes, ORB from 1,024 bytes (32 landmarks, F1 76.1) to 14,560 bytes (455 landmarks, F1 90.8)."/>
+          <p:cNvPicPr>
+            <a:picLocks noChangeAspect="1"/>
+          </p:cNvPicPr>
+          <p:nvPr/>
+        </p:nvPicPr>
+        <p:blipFill>
+          <a:blip r:embed="rId20"/>
+          <a:stretch>
+            <a:fillRect/>
+          </a:stretch>
+        </p:blipFill>
+        <p:spPr>
+          <a:xfrm>
+            <a:off x="8366760" y="2377440"/>
+            <a:ext cx="7159000" cy="4688761"/>
+          </a:xfrm>
+          <a:prstGeom prst="rect">
+            <a:avLst/>
+          </a:prstGeom>
+        </p:spPr>
+      </p:pic>
       <p:sp>
         <p:nvSpPr>
           <p:cNvPr id="12" name="Shape 10"/>

</xml_diff>